<commit_message>
DATA-04: rebrand synthetic sources and prepare Valentino product data
</commit_message>
<xml_diff>
--- a/generated/sources/reports/apac/APAC_Monthly_Review_SEP2026_v1.1.pptx
+++ b/generated/sources/reports/apac/APAC_Monthly_Review_SEP2026_v1.1.pptx
@@ -631,7 +631,7 @@
           <a:p>
             <a:r>
               <a:rPr sz="1100" b="1"/>
-              <a:t>POLARIS units sold 24-30/9 by APAC market</a:t>
+              <a:t>ASTRA units sold 24-30/9 by APAC market</a:t>
             </a:r>
           </a:p>
         </c:rich>
@@ -981,19 +981,19 @@
               <c:strCache>
                 <c:ptCount val="5"/>
                 <c:pt idx="0">
-                  <c:v>AMBRINE</c:v>
+                  <c:v>AMALIA</c:v>
                 </c:pt>
                 <c:pt idx="1">
-                  <c:v>ARNEB</c:v>
+                  <c:v>ARTEM</c:v>
                 </c:pt>
                 <c:pt idx="2">
-                  <c:v>ILVARO</c:v>
+                  <c:v>IRIDIA</c:v>
                 </c:pt>
                 <c:pt idx="3">
-                  <c:v>ROSIERE</c:v>
+                  <c:v>RIVIERA</c:v>
                 </c:pt>
                 <c:pt idx="4">
-                  <c:v>WOOL TURTLENECK</c:v>
+                  <c:v>CASHMERE TURTLENECK</c:v>
                 </c:pt>
               </c:strCache>
             </c:strRef>
@@ -1048,19 +1048,19 @@
               <c:strCache>
                 <c:ptCount val="5"/>
                 <c:pt idx="0">
-                  <c:v>AMBRINE</c:v>
+                  <c:v>AMALIA</c:v>
                 </c:pt>
                 <c:pt idx="1">
-                  <c:v>ARNEB</c:v>
+                  <c:v>ARTEM</c:v>
                 </c:pt>
                 <c:pt idx="2">
-                  <c:v>ILVARO</c:v>
+                  <c:v>IRIDIA</c:v>
                 </c:pt>
                 <c:pt idx="3">
-                  <c:v>ROSIERE</c:v>
+                  <c:v>RIVIERA</c:v>
                 </c:pt>
                 <c:pt idx="4">
-                  <c:v>WOOL TURTLENECK</c:v>
+                  <c:v>CASHMERE TURTLENECK</c:v>
                 </c:pt>
               </c:strCache>
             </c:strRef>
@@ -1115,19 +1115,19 @@
               <c:strCache>
                 <c:ptCount val="5"/>
                 <c:pt idx="0">
-                  <c:v>AMBRINE</c:v>
+                  <c:v>AMALIA</c:v>
                 </c:pt>
                 <c:pt idx="1">
-                  <c:v>ARNEB</c:v>
+                  <c:v>ARTEM</c:v>
                 </c:pt>
                 <c:pt idx="2">
-                  <c:v>ILVARO</c:v>
+                  <c:v>IRIDIA</c:v>
                 </c:pt>
                 <c:pt idx="3">
-                  <c:v>ROSIERE</c:v>
+                  <c:v>RIVIERA</c:v>
                 </c:pt>
                 <c:pt idx="4">
-                  <c:v>WOOL TURTLENECK</c:v>
+                  <c:v>CASHMERE TURTLENECK</c:v>
                 </c:pt>
               </c:strCache>
             </c:strRef>
@@ -1182,19 +1182,19 @@
               <c:strCache>
                 <c:ptCount val="5"/>
                 <c:pt idx="0">
-                  <c:v>AMBRINE</c:v>
+                  <c:v>AMALIA</c:v>
                 </c:pt>
                 <c:pt idx="1">
-                  <c:v>ARNEB</c:v>
+                  <c:v>ARTEM</c:v>
                 </c:pt>
                 <c:pt idx="2">
-                  <c:v>ILVARO</c:v>
+                  <c:v>IRIDIA</c:v>
                 </c:pt>
                 <c:pt idx="3">
-                  <c:v>ROSIERE</c:v>
+                  <c:v>RIVIERA</c:v>
                 </c:pt>
                 <c:pt idx="4">
-                  <c:v>WOOL TURTLENECK</c:v>
+                  <c:v>CASHMERE TURTLENECK</c:v>
                 </c:pt>
               </c:strCache>
             </c:strRef>
@@ -1249,19 +1249,19 @@
               <c:strCache>
                 <c:ptCount val="5"/>
                 <c:pt idx="0">
-                  <c:v>AMBRINE</c:v>
+                  <c:v>AMALIA</c:v>
                 </c:pt>
                 <c:pt idx="1">
-                  <c:v>ARNEB</c:v>
+                  <c:v>ARTEM</c:v>
                 </c:pt>
                 <c:pt idx="2">
-                  <c:v>ILVARO</c:v>
+                  <c:v>IRIDIA</c:v>
                 </c:pt>
                 <c:pt idx="3">
-                  <c:v>ROSIERE</c:v>
+                  <c:v>RIVIERA</c:v>
                 </c:pt>
                 <c:pt idx="4">
-                  <c:v>WOOL TURTLENECK</c:v>
+                  <c:v>CASHMERE TURTLENECK</c:v>
                 </c:pt>
               </c:strCache>
             </c:strRef>
@@ -1316,19 +1316,19 @@
               <c:strCache>
                 <c:ptCount val="5"/>
                 <c:pt idx="0">
-                  <c:v>AMBRINE</c:v>
+                  <c:v>AMALIA</c:v>
                 </c:pt>
                 <c:pt idx="1">
-                  <c:v>ARNEB</c:v>
+                  <c:v>ARTEM</c:v>
                 </c:pt>
                 <c:pt idx="2">
-                  <c:v>ILVARO</c:v>
+                  <c:v>IRIDIA</c:v>
                 </c:pt>
                 <c:pt idx="3">
-                  <c:v>ROSIERE</c:v>
+                  <c:v>RIVIERA</c:v>
                 </c:pt>
                 <c:pt idx="4">
-                  <c:v>WOOL TURTLENECK</c:v>
+                  <c:v>CASHMERE TURTLENECK</c:v>
                 </c:pt>
               </c:strCache>
             </c:strRef>
@@ -1456,7 +1456,7 @@
           <a:p>
             <a:r>
               <a:rPr sz="1100" b="1"/>
-              <a:t>ILVARO powder pink - APAC daily units</a:t>
+              <a:t>IRIDIA powder pink - APAC daily units</a:t>
             </a:r>
           </a:p>
         </c:rich>
@@ -1478,7 +1478,7 @@
               <c:strCache>
                 <c:ptCount val="1"/>
                 <c:pt idx="0">
-                  <c:v>ILVARO powder pink units</c:v>
+                  <c:v>IRIDIA powder pink units</c:v>
                 </c:pt>
               </c:strCache>
             </c:strRef>
@@ -4992,7 +4992,7 @@
                 </a:solidFill>
                 <a:latin typeface="Arial"/>
               </a:rPr>
-              <a:t>• AMBRINE strongest in Mainland China (long coat silhouette).</a:t>
+              <a:t>• AMALIA strongest in Mainland China (long coat silhouette).</a:t>
             </a:r>
           </a:p>
           <a:p>
@@ -5008,7 +5008,7 @@
                 </a:solidFill>
                 <a:latin typeface="Arial"/>
               </a:rPr>
-              <a:t>• ILVARO launch quantity was small (allocation at 55% of model); black broken early in Seoul.</a:t>
+              <a:t>• IRIDIA launch quantity was small (allocation at 55% of model); black broken early in Seoul.</a:t>
             </a:r>
           </a:p>
           <a:p>
@@ -5024,7 +5024,7 @@
                 </a:solidFill>
                 <a:latin typeface="Arial"/>
               </a:rPr>
-              <a:t>• ARNEB size feedback: fits large.</a:t>
+              <a:t>• ARTEM size feedback: fits large.</a:t>
             </a:r>
           </a:p>
           <a:p>
@@ -5040,7 +5040,7 @@
                 </a:solidFill>
                 <a:latin typeface="Arial"/>
               </a:rPr>
-              <a:t>• Ask HQ: ILVARO re-order for Asia before the celebrity effect fades.</a:t>
+              <a:t>• Ask HQ: IRIDIA re-order for Asia before the celebrity effect fades.</a:t>
             </a:r>
           </a:p>
         </p:txBody>
@@ -5252,7 +5252,7 @@
                 </a:solidFill>
                 <a:latin typeface="Arial"/>
               </a:rPr>
-              <a:t>• Yoon Ha-eun (LUMIERE) photographed in ILVARO powder pink at Paris Fashion Week on 1/10: pink sold out in all Asian stores in 1-3 days.</a:t>
+              <a:t>• Yoon Ha-eun (LUMIERE) photographed in IRIDIA powder pink at Paris Fashion Week on 1/10: pink sold out in all Asian stores in 1-3 days.</a:t>
             </a:r>
           </a:p>
           <a:p>
@@ -5581,7 +5581,7 @@
                           </a:solidFill>
                           <a:latin typeface="Arial"/>
                         </a:rPr>
-                        <a:t>ILVARO pink</a:t>
+                        <a:t>IRIDIA pink</a:t>
                       </a:r>
                     </a:p>
                   </a:txBody>
@@ -5698,7 +5698,7 @@
                           </a:solidFill>
                           <a:latin typeface="Arial"/>
                         </a:rPr>
-                        <a:t>Extra MAYA/MAIRE stock for TYO01/OSA01 before 1/11</a:t>
+                        <a:t>Extra NOVA/AUREA stock for TYO01/OSA01 before 1/11</a:t>
                       </a:r>
                     </a:p>
                   </a:txBody>
@@ -5863,7 +5863,7 @@
                           </a:solidFill>
                           <a:latin typeface="Arial"/>
                         </a:rPr>
-                        <a:t>POLARIS</a:t>
+                        <a:t>ASTRA</a:t>
                       </a:r>
                     </a:p>
                   </a:txBody>
@@ -5886,7 +5886,7 @@
                           </a:solidFill>
                           <a:latin typeface="Arial"/>
                         </a:rPr>
-                        <a:t>Re-allocate EU/US POLARIS stock to Greater China</a:t>
+                        <a:t>Re-allocate EU/US ASTRA stock to Greater China</a:t>
                       </a:r>
                     </a:p>
                   </a:txBody>
@@ -5957,7 +5957,7 @@
                           </a:solidFill>
                           <a:latin typeface="Arial"/>
                         </a:rPr>
-                        <a:t>TIB vest</a:t>
+                        <a:t>VEL vest</a:t>
                       </a:r>
                     </a:p>
                   </a:txBody>
@@ -6557,7 +6557,7 @@
                 </a:solidFill>
                 <a:latin typeface="Arial"/>
               </a:rPr>
-              <a:t>• Greater China leads: POLARIS (Genius) launch on 24/9 sold through fast in Shanghai, Beijing and Chengdu; strong local clientele before Golden Week.</a:t>
+              <a:t>• Greater China leads: ASTRA (Couture) launch on 24/9 sold through fast in Shanghai, Beijing and Chengdu; strong local clientele before Golden Week.</a:t>
             </a:r>
           </a:p>
           <a:p>
@@ -6621,7 +6621,7 @@
                 </a:solidFill>
                 <a:latin typeface="Arial"/>
               </a:rPr>
-              <a:t>• Early October: ILVARO powder pink sold out across Asia within 1-3 days after the LUMIERE / Yoon Ha-eun photos (1/10). We need replenishment.</a:t>
+              <a:t>• Early October: IRIDIA powder pink sold out across Asia within 1-3 days after the LUMIERE / Yoon Ha-eun photos (1/10). We need replenishment.</a:t>
             </a:r>
           </a:p>
           <a:p>
@@ -9055,7 +9055,7 @@
                 </a:solidFill>
                 <a:latin typeface="Arial"/>
               </a:rPr>
-              <a:t>Max temperatures 27-29°C until 11/10: down jackets slow, knit and Trailgrip OK.</a:t>
+              <a:t>Max temperatures 27-29°C until 11/10: down jackets slow, knit and Vtrack OK.</a:t>
             </a:r>
           </a:p>
           <a:p>
@@ -9685,7 +9685,7 @@
                 </a:solidFill>
                 <a:latin typeface="Arial"/>
               </a:rPr>
-              <a:t>Chuseok (24-26/9): many Korean clients travelling to Europe; strong demand for black MAIRE reported by Paris and Milan (Korean shoppers).</a:t>
+              <a:t>Chuseok (24-26/9): many Korean clients travelling to Europe; strong demand for black AUREA reported by Paris and Milan (Korean shoppers).</a:t>
             </a:r>
           </a:p>
           <a:p>
@@ -9701,7 +9701,7 @@
                 </a:solidFill>
                 <a:latin typeface="Arial"/>
               </a:rPr>
-              <a:t>BADY and ILVARO best sellers in women; LOGO HOODIE strong with younger clients.</a:t>
+              <a:t>ARIA and IRIDIA best sellers in women; VLOGO HOODIE strong with younger clients.</a:t>
             </a:r>
           </a:p>
           <a:p>
@@ -9785,7 +9785,7 @@
                 </a:solidFill>
                 <a:latin typeface="Arial"/>
               </a:rPr>
-              <a:t>Greater China - POLARIS is a hit</a:t>
+              <a:t>Greater China - ASTRA is a hit</a:t>
             </a:r>
           </a:p>
         </p:txBody>
@@ -9945,7 +9945,7 @@
                 </a:solidFill>
                 <a:latin typeface="Arial"/>
               </a:rPr>
-              <a:t>Mainland China +19.5% vs LY. POLARIS: 129 units in the first 7 days (vs 77 in all of EMEA).</a:t>
+              <a:t>Mainland China +19.5% vs LY. ASTRA: 129 units in the first 7 days (vs 77 in all of EMEA).</a:t>
             </a:r>
           </a:p>
           <a:p>
@@ -9993,7 +9993,7 @@
                 </a:solidFill>
                 <a:latin typeface="Arial"/>
               </a:rPr>
-              <a:t>「POLARIS 系列上市首周表现超预期，斗篷款多个门店断码」 - 中国区零售团队</a:t>
+              <a:t>「ASTRA 系列上市首周表现超预期，斗篷款多个门店断码」 - 中国区零售团队</a:t>
             </a:r>
           </a:p>
         </p:txBody>

</xml_diff>

<commit_message>
DATA-04: Valentino rebrand and visual product data (#158)
* DATA-04: start

* DATA-04: rebrand synthetic sources and prepare Valentino product data

* DATA-04: refresh rebranded replay inputs and insight hashes
</commit_message>
<xml_diff>
--- a/generated/sources/reports/apac/APAC_Monthly_Review_SEP2026_v1.1.pptx
+++ b/generated/sources/reports/apac/APAC_Monthly_Review_SEP2026_v1.1.pptx
@@ -631,7 +631,7 @@
           <a:p>
             <a:r>
               <a:rPr sz="1100" b="1"/>
-              <a:t>POLARIS units sold 24-30/9 by APAC market</a:t>
+              <a:t>ASTRA units sold 24-30/9 by APAC market</a:t>
             </a:r>
           </a:p>
         </c:rich>
@@ -981,19 +981,19 @@
               <c:strCache>
                 <c:ptCount val="5"/>
                 <c:pt idx="0">
-                  <c:v>AMBRINE</c:v>
+                  <c:v>AMALIA</c:v>
                 </c:pt>
                 <c:pt idx="1">
-                  <c:v>ARNEB</c:v>
+                  <c:v>ARTEM</c:v>
                 </c:pt>
                 <c:pt idx="2">
-                  <c:v>ILVARO</c:v>
+                  <c:v>IRIDIA</c:v>
                 </c:pt>
                 <c:pt idx="3">
-                  <c:v>ROSIERE</c:v>
+                  <c:v>RIVIERA</c:v>
                 </c:pt>
                 <c:pt idx="4">
-                  <c:v>WOOL TURTLENECK</c:v>
+                  <c:v>CASHMERE TURTLENECK</c:v>
                 </c:pt>
               </c:strCache>
             </c:strRef>
@@ -1048,19 +1048,19 @@
               <c:strCache>
                 <c:ptCount val="5"/>
                 <c:pt idx="0">
-                  <c:v>AMBRINE</c:v>
+                  <c:v>AMALIA</c:v>
                 </c:pt>
                 <c:pt idx="1">
-                  <c:v>ARNEB</c:v>
+                  <c:v>ARTEM</c:v>
                 </c:pt>
                 <c:pt idx="2">
-                  <c:v>ILVARO</c:v>
+                  <c:v>IRIDIA</c:v>
                 </c:pt>
                 <c:pt idx="3">
-                  <c:v>ROSIERE</c:v>
+                  <c:v>RIVIERA</c:v>
                 </c:pt>
                 <c:pt idx="4">
-                  <c:v>WOOL TURTLENECK</c:v>
+                  <c:v>CASHMERE TURTLENECK</c:v>
                 </c:pt>
               </c:strCache>
             </c:strRef>
@@ -1115,19 +1115,19 @@
               <c:strCache>
                 <c:ptCount val="5"/>
                 <c:pt idx="0">
-                  <c:v>AMBRINE</c:v>
+                  <c:v>AMALIA</c:v>
                 </c:pt>
                 <c:pt idx="1">
-                  <c:v>ARNEB</c:v>
+                  <c:v>ARTEM</c:v>
                 </c:pt>
                 <c:pt idx="2">
-                  <c:v>ILVARO</c:v>
+                  <c:v>IRIDIA</c:v>
                 </c:pt>
                 <c:pt idx="3">
-                  <c:v>ROSIERE</c:v>
+                  <c:v>RIVIERA</c:v>
                 </c:pt>
                 <c:pt idx="4">
-                  <c:v>WOOL TURTLENECK</c:v>
+                  <c:v>CASHMERE TURTLENECK</c:v>
                 </c:pt>
               </c:strCache>
             </c:strRef>
@@ -1182,19 +1182,19 @@
               <c:strCache>
                 <c:ptCount val="5"/>
                 <c:pt idx="0">
-                  <c:v>AMBRINE</c:v>
+                  <c:v>AMALIA</c:v>
                 </c:pt>
                 <c:pt idx="1">
-                  <c:v>ARNEB</c:v>
+                  <c:v>ARTEM</c:v>
                 </c:pt>
                 <c:pt idx="2">
-                  <c:v>ILVARO</c:v>
+                  <c:v>IRIDIA</c:v>
                 </c:pt>
                 <c:pt idx="3">
-                  <c:v>ROSIERE</c:v>
+                  <c:v>RIVIERA</c:v>
                 </c:pt>
                 <c:pt idx="4">
-                  <c:v>WOOL TURTLENECK</c:v>
+                  <c:v>CASHMERE TURTLENECK</c:v>
                 </c:pt>
               </c:strCache>
             </c:strRef>
@@ -1249,19 +1249,19 @@
               <c:strCache>
                 <c:ptCount val="5"/>
                 <c:pt idx="0">
-                  <c:v>AMBRINE</c:v>
+                  <c:v>AMALIA</c:v>
                 </c:pt>
                 <c:pt idx="1">
-                  <c:v>ARNEB</c:v>
+                  <c:v>ARTEM</c:v>
                 </c:pt>
                 <c:pt idx="2">
-                  <c:v>ILVARO</c:v>
+                  <c:v>IRIDIA</c:v>
                 </c:pt>
                 <c:pt idx="3">
-                  <c:v>ROSIERE</c:v>
+                  <c:v>RIVIERA</c:v>
                 </c:pt>
                 <c:pt idx="4">
-                  <c:v>WOOL TURTLENECK</c:v>
+                  <c:v>CASHMERE TURTLENECK</c:v>
                 </c:pt>
               </c:strCache>
             </c:strRef>
@@ -1316,19 +1316,19 @@
               <c:strCache>
                 <c:ptCount val="5"/>
                 <c:pt idx="0">
-                  <c:v>AMBRINE</c:v>
+                  <c:v>AMALIA</c:v>
                 </c:pt>
                 <c:pt idx="1">
-                  <c:v>ARNEB</c:v>
+                  <c:v>ARTEM</c:v>
                 </c:pt>
                 <c:pt idx="2">
-                  <c:v>ILVARO</c:v>
+                  <c:v>IRIDIA</c:v>
                 </c:pt>
                 <c:pt idx="3">
-                  <c:v>ROSIERE</c:v>
+                  <c:v>RIVIERA</c:v>
                 </c:pt>
                 <c:pt idx="4">
-                  <c:v>WOOL TURTLENECK</c:v>
+                  <c:v>CASHMERE TURTLENECK</c:v>
                 </c:pt>
               </c:strCache>
             </c:strRef>
@@ -1456,7 +1456,7 @@
           <a:p>
             <a:r>
               <a:rPr sz="1100" b="1"/>
-              <a:t>ILVARO powder pink - APAC daily units</a:t>
+              <a:t>IRIDIA powder pink - APAC daily units</a:t>
             </a:r>
           </a:p>
         </c:rich>
@@ -1478,7 +1478,7 @@
               <c:strCache>
                 <c:ptCount val="1"/>
                 <c:pt idx="0">
-                  <c:v>ILVARO powder pink units</c:v>
+                  <c:v>IRIDIA powder pink units</c:v>
                 </c:pt>
               </c:strCache>
             </c:strRef>
@@ -4992,7 +4992,7 @@
                 </a:solidFill>
                 <a:latin typeface="Arial"/>
               </a:rPr>
-              <a:t>• AMBRINE strongest in Mainland China (long coat silhouette).</a:t>
+              <a:t>• AMALIA strongest in Mainland China (long coat silhouette).</a:t>
             </a:r>
           </a:p>
           <a:p>
@@ -5008,7 +5008,7 @@
                 </a:solidFill>
                 <a:latin typeface="Arial"/>
               </a:rPr>
-              <a:t>• ILVARO launch quantity was small (allocation at 55% of model); black broken early in Seoul.</a:t>
+              <a:t>• IRIDIA launch quantity was small (allocation at 55% of model); black broken early in Seoul.</a:t>
             </a:r>
           </a:p>
           <a:p>
@@ -5024,7 +5024,7 @@
                 </a:solidFill>
                 <a:latin typeface="Arial"/>
               </a:rPr>
-              <a:t>• ARNEB size feedback: fits large.</a:t>
+              <a:t>• ARTEM size feedback: fits large.</a:t>
             </a:r>
           </a:p>
           <a:p>
@@ -5040,7 +5040,7 @@
                 </a:solidFill>
                 <a:latin typeface="Arial"/>
               </a:rPr>
-              <a:t>• Ask HQ: ILVARO re-order for Asia before the celebrity effect fades.</a:t>
+              <a:t>• Ask HQ: IRIDIA re-order for Asia before the celebrity effect fades.</a:t>
             </a:r>
           </a:p>
         </p:txBody>
@@ -5252,7 +5252,7 @@
                 </a:solidFill>
                 <a:latin typeface="Arial"/>
               </a:rPr>
-              <a:t>• Yoon Ha-eun (LUMIERE) photographed in ILVARO powder pink at Paris Fashion Week on 1/10: pink sold out in all Asian stores in 1-3 days.</a:t>
+              <a:t>• Yoon Ha-eun (LUMIERE) photographed in IRIDIA powder pink at Paris Fashion Week on 1/10: pink sold out in all Asian stores in 1-3 days.</a:t>
             </a:r>
           </a:p>
           <a:p>
@@ -5581,7 +5581,7 @@
                           </a:solidFill>
                           <a:latin typeface="Arial"/>
                         </a:rPr>
-                        <a:t>ILVARO pink</a:t>
+                        <a:t>IRIDIA pink</a:t>
                       </a:r>
                     </a:p>
                   </a:txBody>
@@ -5698,7 +5698,7 @@
                           </a:solidFill>
                           <a:latin typeface="Arial"/>
                         </a:rPr>
-                        <a:t>Extra MAYA/MAIRE stock for TYO01/OSA01 before 1/11</a:t>
+                        <a:t>Extra NOVA/AUREA stock for TYO01/OSA01 before 1/11</a:t>
                       </a:r>
                     </a:p>
                   </a:txBody>
@@ -5863,7 +5863,7 @@
                           </a:solidFill>
                           <a:latin typeface="Arial"/>
                         </a:rPr>
-                        <a:t>POLARIS</a:t>
+                        <a:t>ASTRA</a:t>
                       </a:r>
                     </a:p>
                   </a:txBody>
@@ -5886,7 +5886,7 @@
                           </a:solidFill>
                           <a:latin typeface="Arial"/>
                         </a:rPr>
-                        <a:t>Re-allocate EU/US POLARIS stock to Greater China</a:t>
+                        <a:t>Re-allocate EU/US ASTRA stock to Greater China</a:t>
                       </a:r>
                     </a:p>
                   </a:txBody>
@@ -5957,7 +5957,7 @@
                           </a:solidFill>
                           <a:latin typeface="Arial"/>
                         </a:rPr>
-                        <a:t>TIB vest</a:t>
+                        <a:t>VEL vest</a:t>
                       </a:r>
                     </a:p>
                   </a:txBody>
@@ -6557,7 +6557,7 @@
                 </a:solidFill>
                 <a:latin typeface="Arial"/>
               </a:rPr>
-              <a:t>• Greater China leads: POLARIS (Genius) launch on 24/9 sold through fast in Shanghai, Beijing and Chengdu; strong local clientele before Golden Week.</a:t>
+              <a:t>• Greater China leads: ASTRA (Couture) launch on 24/9 sold through fast in Shanghai, Beijing and Chengdu; strong local clientele before Golden Week.</a:t>
             </a:r>
           </a:p>
           <a:p>
@@ -6621,7 +6621,7 @@
                 </a:solidFill>
                 <a:latin typeface="Arial"/>
               </a:rPr>
-              <a:t>• Early October: ILVARO powder pink sold out across Asia within 1-3 days after the LUMIERE / Yoon Ha-eun photos (1/10). We need replenishment.</a:t>
+              <a:t>• Early October: IRIDIA powder pink sold out across Asia within 1-3 days after the LUMIERE / Yoon Ha-eun photos (1/10). We need replenishment.</a:t>
             </a:r>
           </a:p>
           <a:p>
@@ -9055,7 +9055,7 @@
                 </a:solidFill>
                 <a:latin typeface="Arial"/>
               </a:rPr>
-              <a:t>Max temperatures 27-29°C until 11/10: down jackets slow, knit and Trailgrip OK.</a:t>
+              <a:t>Max temperatures 27-29°C until 11/10: down jackets slow, knit and Vtrack OK.</a:t>
             </a:r>
           </a:p>
           <a:p>
@@ -9685,7 +9685,7 @@
                 </a:solidFill>
                 <a:latin typeface="Arial"/>
               </a:rPr>
-              <a:t>Chuseok (24-26/9): many Korean clients travelling to Europe; strong demand for black MAIRE reported by Paris and Milan (Korean shoppers).</a:t>
+              <a:t>Chuseok (24-26/9): many Korean clients travelling to Europe; strong demand for black AUREA reported by Paris and Milan (Korean shoppers).</a:t>
             </a:r>
           </a:p>
           <a:p>
@@ -9701,7 +9701,7 @@
                 </a:solidFill>
                 <a:latin typeface="Arial"/>
               </a:rPr>
-              <a:t>BADY and ILVARO best sellers in women; LOGO HOODIE strong with younger clients.</a:t>
+              <a:t>ARIA and IRIDIA best sellers in women; VLOGO HOODIE strong with younger clients.</a:t>
             </a:r>
           </a:p>
           <a:p>
@@ -9785,7 +9785,7 @@
                 </a:solidFill>
                 <a:latin typeface="Arial"/>
               </a:rPr>
-              <a:t>Greater China - POLARIS is a hit</a:t>
+              <a:t>Greater China - ASTRA is a hit</a:t>
             </a:r>
           </a:p>
         </p:txBody>
@@ -9945,7 +9945,7 @@
                 </a:solidFill>
                 <a:latin typeface="Arial"/>
               </a:rPr>
-              <a:t>Mainland China +19.5% vs LY. POLARIS: 129 units in the first 7 days (vs 77 in all of EMEA).</a:t>
+              <a:t>Mainland China +19.5% vs LY. ASTRA: 129 units in the first 7 days (vs 77 in all of EMEA).</a:t>
             </a:r>
           </a:p>
           <a:p>
@@ -9993,7 +9993,7 @@
                 </a:solidFill>
                 <a:latin typeface="Arial"/>
               </a:rPr>
-              <a:t>「POLARIS 系列上市首周表现超预期，斗篷款多个门店断码」 - 中国区零售团队</a:t>
+              <a:t>「ASTRA 系列上市首周表现超预期，斗篷款多个门店断码」 - 中国区零售团队</a:t>
             </a:r>
           </a:p>
         </p:txBody>

</xml_diff>